<commit_message>
Proofread scicode slides page by page with Gemini
</commit_message>
<xml_diff>
--- a/slides/datasets-in-10-minutes-scicode.pptx
+++ b/slides/datasets-in-10-minutes-scicode.pptx
@@ -8025,7 +8025,7 @@
                 <a:ea typeface="Noto Sans CJK JP"/>
                 <a:cs typeface="Noto Sans"/>
               </a:rPr>
-              <a:t>Lennard–Jonesポテンシャルは、2原子の距離から相互作用のエネルギーを求める。σは値が0となる距離、εは井戸の深さを表す。</a:t>
+              <a:t>Lennard–Jonesポテンシャルは、2原子間の距離から相互作用エネルギーを計算する。σは値が0となる距離、εは井戸の深さを表す。</a:t>
             </a:r>
           </a:p>
         </p:txBody>
@@ -10218,7 +10218,7 @@
                 <a:ea typeface="Noto Sans CJK JP"/>
                 <a:cs typeface="Noto Sans"/>
               </a:rPr>
-              <a:t>例：2次元Isingモデルの相転移温度や、</a:t>
+              <a:t>分野固有の検証の例：2次元Isingモデルの相転移温度や、</a:t>
             </a:r>
           </a:p>
           <a:p>
@@ -10875,7 +10875,7 @@
                 <a:ea typeface="Noto Sans CJK JP"/>
                 <a:cs typeface="Noto Sans"/>
               </a:rPr>
-              <a:t>標準設定は、科学的な背景説明を与えず、前段階にはモデル自身が生成したコードを使う。</a:t>
+              <a:t>標準設定では、科学的な背景説明を与えず、前段階にはモデル自身が生成したコードを使う。</a:t>
             </a:r>
           </a:p>
         </p:txBody>
@@ -13838,7 +13838,7 @@
                 <a:spcPts val="2640"/>
               </a:lnSpc>
               <a:spcAft>
-                <a:spcPts val="800"/>
+                <a:spcPts val="0"/>
               </a:spcAft>
               <a:buSzPct val="60455"/>
               <a:buFont typeface="Noto Sans CJK JP"/>
@@ -13859,7 +13859,7 @@
                 <a:ea typeface="Noto Sans CJK JP"/>
                 <a:cs typeface="Noto Sans"/>
               </a:rPr>
-              <a:t>背景説明ありでは、科学者が書いた科学的な知識や計算手順をプロンプトへ加える。なしでは、モデル自身が必要な知識を補う。</a:t>
+              <a:t>背景説明の有無と、前段階のコードの出所という2つの軸で、科学知識とコード生成を調べる。</a:t>
             </a:r>
           </a:p>
           <a:p>
@@ -13889,7 +13889,7 @@
                 <a:ea typeface="Noto Sans CJK JP"/>
                 <a:cs typeface="Noto Sans"/>
               </a:rPr>
-              <a:t>前段階に参照解を使う設定では、対象の部分問題の実装能力に焦点を当てる。生成コードを使う設定では、前の段階からの誤りも引き継ぐ。</a:t>
+              <a:t>背景説明ありでは、科学者が書いた科学的な知識や計算手順をプロンプトへ加える。なしでは、モデル自身が必要な知識を補う。</a:t>
             </a:r>
           </a:p>
           <a:p>
@@ -13898,7 +13898,7 @@
                 <a:spcPts val="2640"/>
               </a:lnSpc>
               <a:spcAft>
-                <a:spcPts val="0"/>
+                <a:spcPts val="800"/>
               </a:spcAft>
               <a:buSzPct val="60455"/>
               <a:buFont typeface="Noto Sans CJK JP"/>
@@ -13919,7 +13919,7 @@
                 <a:ea typeface="Noto Sans CJK JP"/>
                 <a:cs typeface="Noto Sans"/>
               </a:rPr>
-              <a:t>背景説明の有無と、前段階のコードの出所という2つの軸で、科学知識とコード生成を調べる。</a:t>
+              <a:t>前段階に参照解を使う設定では、対象の部分問題の実装能力に焦点を当てる。生成コードを使う設定では、前の段階からの誤りも引き継ぐ。</a:t>
             </a:r>
           </a:p>
         </p:txBody>
@@ -15523,7 +15523,7 @@
                 <a:ea typeface="Noto Sans CJK JP"/>
                 <a:cs typeface="Noto Sans"/>
               </a:rPr>
-              <a:t>80主課題は5分野にまたがる</a:t>
+              <a:t>80の主課題は5分野にまたがる</a:t>
             </a:r>
           </a:p>
         </p:txBody>
@@ -17014,7 +17014,7 @@
         </p:nvSpPr>
         <p:spPr>
           <a:xfrm>
-            <a:off x="594360" y="4096512"/>
+            <a:off x="594360" y="4007612"/>
             <a:ext cx="7955279" cy="420624"/>
           </a:xfrm>
           <a:prstGeom prst="rect">
@@ -17055,7 +17055,7 @@
                 <a:ea typeface="Noto Sans CJK JP"/>
                 <a:cs typeface="Noto Sans"/>
               </a:rPr>
-              <a:t>80主課題を集計。固定コード3件を除き、生成する段階数で分類。</a:t>
+              <a:t>縦軸は主課題数。80主課題を集計し、固定コードの3段階を除いた生成段階数で分類する。</a:t>
             </a:r>
           </a:p>
         </p:txBody>
@@ -18761,7 +18761,7 @@
                 <a:ea typeface="Noto Sans CJK JP"/>
                 <a:cs typeface="Noto Sans"/>
               </a:rPr>
-              <a:t>3段階は固定コードを後続の計算へ渡す</a:t>
+              <a:t>3つの段階で、固定コードを後続の計算へ渡す</a:t>
             </a:r>
           </a:p>
         </p:txBody>
@@ -19557,7 +19557,7 @@
                 <a:ea typeface="Noto Sans CJK JP"/>
                 <a:cs typeface="Noto Sans"/>
               </a:rPr>
-              <a:t>SciCodeは、科学者が作成した80主課題から、338の生成対象の部分問題を構成する。</a:t>
+              <a:t>SciCodeは、科学者が作成した80の主課題を、生成対象となる338の部分問題に分けたものである。</a:t>
             </a:r>
           </a:p>
           <a:p>
@@ -27795,7 +27795,7 @@
                 <a:ea typeface="Noto Sans CJK JP"/>
                 <a:cs typeface="Noto Sans"/>
               </a:rPr>
-              <a:t>数学・物理・化学・生物・材料科学の5分野にわたる80の主課題を、338の生成対象の部分問題へ分けている。</a:t>
+              <a:t>数学・物理・化学・生物・材料科学の5分野にわたる80の主課題を、生成対象となる338の部分問題に分けている。</a:t>
             </a:r>
           </a:p>
           <a:p>
@@ -33013,7 +33013,7 @@
                 <a:ea typeface="Noto Sans CJK JP"/>
                 <a:cs typeface="Noto Sans"/>
               </a:rPr>
-              <a:t>一つの研究課題を、複数の関数へ分ける</a:t>
+              <a:t>Gram–Schmidt直交化を複数の関数に分ける</a:t>
             </a:r>
           </a:p>
         </p:txBody>
@@ -34435,7 +34435,7 @@
                 <a:ea typeface="Noto Sans CJK JP"/>
                 <a:cs typeface="Noto Sans"/>
               </a:rPr>
-              <a:t>正規化：入力[3, 4]を[0.6, 0.8]へ変える</a:t>
+              <a:t>正規化：入力[3, 4]を[0.6, 0.8]に変換する</a:t>
             </a:r>
           </a:p>
         </p:txBody>
@@ -34702,7 +34702,7 @@
                 <a:ea typeface="Noto Sans CJK JP"/>
                 <a:cs typeface="Noto Sans"/>
               </a:rPr>
-              <a:t>配布テストの入力はv = [3, 4]。参照解を実行すると[0.6, 0.8]となる。参照解はノルムで割り、ゼロベクトルは変更しない。</a:t>
+              <a:t>配布テストの入力はv = [3, 4]。参照解を実行すると[0.6, 0.8]となる。参照解ではノルムで割り、ゼロベクトルは変更しない。</a:t>
             </a:r>
           </a:p>
         </p:txBody>

</xml_diff>